<commit_message>
Updated position of slides in PowerPoint
</commit_message>
<xml_diff>
--- a/Semester Project.pptx
+++ b/Semester Project.pptx
@@ -10,8 +10,8 @@
   <p:sldIdLst>
     <p:sldId id="256" r:id="rId2"/>
     <p:sldId id="257" r:id="rId3"/>
-    <p:sldId id="262" r:id="rId4"/>
-    <p:sldId id="263" r:id="rId5"/>
+    <p:sldId id="263" r:id="rId4"/>
+    <p:sldId id="262" r:id="rId5"/>
     <p:sldId id="264" r:id="rId6"/>
   </p:sldIdLst>
   <p:sldSz cx="12192000" cy="6858000"/>
@@ -794,7 +794,7 @@
           <a:p>
             <a:fld id="{50B8602A-CA5E-3F4A-BBF0-BD62BAE0270B}" type="slidenum">
               <a:rPr lang="en-US" smtClean="0"/>
-              <a:t>3</a:t>
+              <a:t>4</a:t>
             </a:fld>
             <a:endParaRPr lang="en-US"/>
           </a:p>
@@ -4336,7 +4336,7 @@
                 </a:solidFill>
                 <a:latin typeface="Cooper Black" panose="0208090404030B020404" pitchFamily="18" charset="77"/>
               </a:rPr>
-              <a:t>Game Dev minor</a:t>
+              <a:t>Game Design and Development focus + minor</a:t>
             </a:r>
           </a:p>
           <a:p>
@@ -4413,240 +4413,6 @@
 </file>
 
 <file path=ppt/slides/slide3.xml><?xml version="1.0" encoding="utf-8"?>
-<p:sld xmlns:a="http://schemas.openxmlformats.org/drawingml/2006/main" xmlns:r="http://schemas.openxmlformats.org/officeDocument/2006/relationships" xmlns:p="http://schemas.openxmlformats.org/presentationml/2006/main">
-  <p:cSld>
-    <p:spTree>
-      <p:nvGrpSpPr>
-        <p:cNvPr id="1" name="">
-          <a:extLst>
-            <a:ext uri="{FF2B5EF4-FFF2-40B4-BE49-F238E27FC236}">
-              <a16:creationId xmlns:a16="http://schemas.microsoft.com/office/drawing/2014/main" id="{5F738785-F840-AE02-2DC4-873726DA068A}"/>
-            </a:ext>
-          </a:extLst>
-        </p:cNvPr>
-        <p:cNvGrpSpPr/>
-        <p:nvPr/>
-      </p:nvGrpSpPr>
-      <p:grpSpPr>
-        <a:xfrm>
-          <a:off x="0" y="0"/>
-          <a:ext cx="0" cy="0"/>
-          <a:chOff x="0" y="0"/>
-          <a:chExt cx="0" cy="0"/>
-        </a:xfrm>
-      </p:grpSpPr>
-      <p:pic>
-        <p:nvPicPr>
-          <p:cNvPr id="4" name="Picture 3" descr="Pixel sky">
-            <a:extLst>
-              <a:ext uri="{FF2B5EF4-FFF2-40B4-BE49-F238E27FC236}">
-                <a16:creationId xmlns:a16="http://schemas.microsoft.com/office/drawing/2014/main" id="{DCF1334C-8976-3783-34FF-152073A8E584}"/>
-              </a:ext>
-            </a:extLst>
-          </p:cNvPr>
-          <p:cNvPicPr>
-            <a:picLocks noChangeAspect="1"/>
-          </p:cNvPicPr>
-          <p:nvPr/>
-        </p:nvPicPr>
-        <p:blipFill>
-          <a:blip r:embed="rId3">
-            <a:extLst>
-              <a:ext uri="{BEBA8EAE-BF5A-486C-A8C5-ECC9F3942E4B}">
-                <a14:imgProps xmlns:a14="http://schemas.microsoft.com/office/drawing/2010/main">
-                  <a14:imgLayer r:embed="rId4">
-                    <a14:imgEffect>
-                      <a14:sharpenSoften amount="-100000"/>
-                    </a14:imgEffect>
-                    <a14:imgEffect>
-                      <a14:brightnessContrast bright="-35000"/>
-                    </a14:imgEffect>
-                  </a14:imgLayer>
-                </a14:imgProps>
-              </a:ext>
-            </a:extLst>
-          </a:blip>
-          <a:stretch>
-            <a:fillRect/>
-          </a:stretch>
-        </p:blipFill>
-        <p:spPr>
-          <a:xfrm>
-            <a:off x="0" y="1071"/>
-            <a:ext cx="12193906" cy="6856929"/>
-          </a:xfrm>
-          <a:prstGeom prst="rect">
-            <a:avLst/>
-          </a:prstGeom>
-        </p:spPr>
-      </p:pic>
-      <p:sp>
-        <p:nvSpPr>
-          <p:cNvPr id="2" name="Title 1">
-            <a:extLst>
-              <a:ext uri="{FF2B5EF4-FFF2-40B4-BE49-F238E27FC236}">
-                <a16:creationId xmlns:a16="http://schemas.microsoft.com/office/drawing/2014/main" id="{348EF9B4-43E6-E514-8D99-B7A5A474C902}"/>
-              </a:ext>
-            </a:extLst>
-          </p:cNvPr>
-          <p:cNvSpPr>
-            <a:spLocks noGrp="1"/>
-          </p:cNvSpPr>
-          <p:nvPr>
-            <p:ph type="title"/>
-          </p:nvPr>
-        </p:nvSpPr>
-        <p:spPr/>
-        <p:txBody>
-          <a:bodyPr/>
-          <a:lstStyle/>
-          <a:p>
-            <a:r>
-              <a:rPr lang="en-US" dirty="0">
-                <a:ln w="28575">
-                  <a:solidFill>
-                    <a:schemeClr val="tx1"/>
-                  </a:solidFill>
-                </a:ln>
-                <a:solidFill>
-                  <a:schemeClr val="bg1"/>
-                </a:solidFill>
-                <a:latin typeface="Cooper Black" panose="0208090404030B020404" pitchFamily="18" charset="77"/>
-              </a:rPr>
-              <a:t>Code</a:t>
-            </a:r>
-          </a:p>
-        </p:txBody>
-      </p:sp>
-      <p:pic>
-        <p:nvPicPr>
-          <p:cNvPr id="10" name="Picture 9">
-            <a:extLst>
-              <a:ext uri="{FF2B5EF4-FFF2-40B4-BE49-F238E27FC236}">
-                <a16:creationId xmlns:a16="http://schemas.microsoft.com/office/drawing/2014/main" id="{E8D5CED9-253D-10DF-C701-25BF4C2B07BB}"/>
-              </a:ext>
-            </a:extLst>
-          </p:cNvPr>
-          <p:cNvPicPr>
-            <a:picLocks noChangeAspect="1"/>
-          </p:cNvPicPr>
-          <p:nvPr/>
-        </p:nvPicPr>
-        <p:blipFill>
-          <a:blip r:embed="rId5"/>
-          <a:stretch>
-            <a:fillRect/>
-          </a:stretch>
-        </p:blipFill>
-        <p:spPr>
-          <a:xfrm>
-            <a:off x="6148542" y="1421697"/>
-            <a:ext cx="5625311" cy="4981003"/>
-          </a:xfrm>
-          <a:prstGeom prst="rect">
-            <a:avLst/>
-          </a:prstGeom>
-          <a:ln>
-            <a:solidFill>
-              <a:schemeClr val="bg1"/>
-            </a:solidFill>
-          </a:ln>
-        </p:spPr>
-      </p:pic>
-      <p:pic>
-        <p:nvPicPr>
-          <p:cNvPr id="12" name="Picture 11">
-            <a:extLst>
-              <a:ext uri="{FF2B5EF4-FFF2-40B4-BE49-F238E27FC236}">
-                <a16:creationId xmlns:a16="http://schemas.microsoft.com/office/drawing/2014/main" id="{3A4C90B6-4484-9DCC-8F17-839837DC4354}"/>
-              </a:ext>
-            </a:extLst>
-          </p:cNvPr>
-          <p:cNvPicPr>
-            <a:picLocks noChangeAspect="1"/>
-          </p:cNvPicPr>
-          <p:nvPr/>
-        </p:nvPicPr>
-        <p:blipFill>
-          <a:blip r:embed="rId6"/>
-          <a:stretch>
-            <a:fillRect/>
-          </a:stretch>
-        </p:blipFill>
-        <p:spPr>
-          <a:xfrm>
-            <a:off x="708913" y="1331523"/>
-            <a:ext cx="4878766" cy="5161352"/>
-          </a:xfrm>
-          <a:prstGeom prst="rect">
-            <a:avLst/>
-          </a:prstGeom>
-          <a:ln>
-            <a:solidFill>
-              <a:schemeClr val="bg1"/>
-            </a:solidFill>
-          </a:ln>
-        </p:spPr>
-      </p:pic>
-      <p:sp>
-        <p:nvSpPr>
-          <p:cNvPr id="13" name="Content Placeholder 2">
-            <a:extLst>
-              <a:ext uri="{FF2B5EF4-FFF2-40B4-BE49-F238E27FC236}">
-                <a16:creationId xmlns:a16="http://schemas.microsoft.com/office/drawing/2014/main" id="{4B52CA67-74DA-CE30-6357-BD156AF87FE4}"/>
-              </a:ext>
-            </a:extLst>
-          </p:cNvPr>
-          <p:cNvSpPr>
-            <a:spLocks noGrp="1"/>
-          </p:cNvSpPr>
-          <p:nvPr>
-            <p:ph idx="1"/>
-          </p:nvPr>
-        </p:nvSpPr>
-        <p:spPr>
-          <a:xfrm>
-            <a:off x="9350138" y="6492875"/>
-            <a:ext cx="3124200" cy="549275"/>
-          </a:xfrm>
-        </p:spPr>
-        <p:txBody>
-          <a:bodyPr>
-            <a:normAutofit/>
-          </a:bodyPr>
-          <a:lstStyle/>
-          <a:p>
-            <a:r>
-              <a:rPr lang="en-US" sz="1400" dirty="0">
-                <a:ln w="3175">
-                  <a:solidFill>
-                    <a:schemeClr val="tx1"/>
-                  </a:solidFill>
-                </a:ln>
-                <a:solidFill>
-                  <a:schemeClr val="bg1"/>
-                </a:solidFill>
-                <a:latin typeface="Cooper Black" panose="0208090404030B020404" pitchFamily="18" charset="77"/>
-              </a:rPr>
-              <a:t>Note: I followed a tutorial</a:t>
-            </a:r>
-          </a:p>
-        </p:txBody>
-      </p:sp>
-    </p:spTree>
-    <p:extLst>
-      <p:ext uri="{BB962C8B-B14F-4D97-AF65-F5344CB8AC3E}">
-        <p14:creationId xmlns:p14="http://schemas.microsoft.com/office/powerpoint/2010/main" val="4008242750"/>
-      </p:ext>
-    </p:extLst>
-  </p:cSld>
-  <p:clrMapOvr>
-    <a:masterClrMapping/>
-  </p:clrMapOvr>
-</p:sld>
-</file>
-
-<file path=ppt/slides/slide4.xml><?xml version="1.0" encoding="utf-8"?>
 <p:sld xmlns:a="http://schemas.openxmlformats.org/drawingml/2006/main" xmlns:r="http://schemas.openxmlformats.org/officeDocument/2006/relationships" xmlns:p="http://schemas.openxmlformats.org/presentationml/2006/main">
   <p:cSld>
     <p:spTree>
@@ -4791,6 +4557,240 @@
     <p:extLst>
       <p:ext uri="{BB962C8B-B14F-4D97-AF65-F5344CB8AC3E}">
         <p14:creationId xmlns:p14="http://schemas.microsoft.com/office/powerpoint/2010/main" val="4020578924"/>
+      </p:ext>
+    </p:extLst>
+  </p:cSld>
+  <p:clrMapOvr>
+    <a:masterClrMapping/>
+  </p:clrMapOvr>
+</p:sld>
+</file>
+
+<file path=ppt/slides/slide4.xml><?xml version="1.0" encoding="utf-8"?>
+<p:sld xmlns:a="http://schemas.openxmlformats.org/drawingml/2006/main" xmlns:r="http://schemas.openxmlformats.org/officeDocument/2006/relationships" xmlns:p="http://schemas.openxmlformats.org/presentationml/2006/main">
+  <p:cSld>
+    <p:spTree>
+      <p:nvGrpSpPr>
+        <p:cNvPr id="1" name="">
+          <a:extLst>
+            <a:ext uri="{FF2B5EF4-FFF2-40B4-BE49-F238E27FC236}">
+              <a16:creationId xmlns:a16="http://schemas.microsoft.com/office/drawing/2014/main" id="{5F738785-F840-AE02-2DC4-873726DA068A}"/>
+            </a:ext>
+          </a:extLst>
+        </p:cNvPr>
+        <p:cNvGrpSpPr/>
+        <p:nvPr/>
+      </p:nvGrpSpPr>
+      <p:grpSpPr>
+        <a:xfrm>
+          <a:off x="0" y="0"/>
+          <a:ext cx="0" cy="0"/>
+          <a:chOff x="0" y="0"/>
+          <a:chExt cx="0" cy="0"/>
+        </a:xfrm>
+      </p:grpSpPr>
+      <p:pic>
+        <p:nvPicPr>
+          <p:cNvPr id="4" name="Picture 3" descr="Pixel sky">
+            <a:extLst>
+              <a:ext uri="{FF2B5EF4-FFF2-40B4-BE49-F238E27FC236}">
+                <a16:creationId xmlns:a16="http://schemas.microsoft.com/office/drawing/2014/main" id="{DCF1334C-8976-3783-34FF-152073A8E584}"/>
+              </a:ext>
+            </a:extLst>
+          </p:cNvPr>
+          <p:cNvPicPr>
+            <a:picLocks noChangeAspect="1"/>
+          </p:cNvPicPr>
+          <p:nvPr/>
+        </p:nvPicPr>
+        <p:blipFill>
+          <a:blip r:embed="rId3">
+            <a:extLst>
+              <a:ext uri="{BEBA8EAE-BF5A-486C-A8C5-ECC9F3942E4B}">
+                <a14:imgProps xmlns:a14="http://schemas.microsoft.com/office/drawing/2010/main">
+                  <a14:imgLayer r:embed="rId4">
+                    <a14:imgEffect>
+                      <a14:sharpenSoften amount="-100000"/>
+                    </a14:imgEffect>
+                    <a14:imgEffect>
+                      <a14:brightnessContrast bright="-35000"/>
+                    </a14:imgEffect>
+                  </a14:imgLayer>
+                </a14:imgProps>
+              </a:ext>
+            </a:extLst>
+          </a:blip>
+          <a:stretch>
+            <a:fillRect/>
+          </a:stretch>
+        </p:blipFill>
+        <p:spPr>
+          <a:xfrm>
+            <a:off x="0" y="1071"/>
+            <a:ext cx="12193906" cy="6856929"/>
+          </a:xfrm>
+          <a:prstGeom prst="rect">
+            <a:avLst/>
+          </a:prstGeom>
+        </p:spPr>
+      </p:pic>
+      <p:sp>
+        <p:nvSpPr>
+          <p:cNvPr id="2" name="Title 1">
+            <a:extLst>
+              <a:ext uri="{FF2B5EF4-FFF2-40B4-BE49-F238E27FC236}">
+                <a16:creationId xmlns:a16="http://schemas.microsoft.com/office/drawing/2014/main" id="{348EF9B4-43E6-E514-8D99-B7A5A474C902}"/>
+              </a:ext>
+            </a:extLst>
+          </p:cNvPr>
+          <p:cNvSpPr>
+            <a:spLocks noGrp="1"/>
+          </p:cNvSpPr>
+          <p:nvPr>
+            <p:ph type="title"/>
+          </p:nvPr>
+        </p:nvSpPr>
+        <p:spPr/>
+        <p:txBody>
+          <a:bodyPr/>
+          <a:lstStyle/>
+          <a:p>
+            <a:r>
+              <a:rPr lang="en-US" dirty="0">
+                <a:ln w="28575">
+                  <a:solidFill>
+                    <a:schemeClr val="tx1"/>
+                  </a:solidFill>
+                </a:ln>
+                <a:solidFill>
+                  <a:schemeClr val="bg1"/>
+                </a:solidFill>
+                <a:latin typeface="Cooper Black" panose="0208090404030B020404" pitchFamily="18" charset="77"/>
+              </a:rPr>
+              <a:t>Code</a:t>
+            </a:r>
+          </a:p>
+        </p:txBody>
+      </p:sp>
+      <p:pic>
+        <p:nvPicPr>
+          <p:cNvPr id="10" name="Picture 9">
+            <a:extLst>
+              <a:ext uri="{FF2B5EF4-FFF2-40B4-BE49-F238E27FC236}">
+                <a16:creationId xmlns:a16="http://schemas.microsoft.com/office/drawing/2014/main" id="{E8D5CED9-253D-10DF-C701-25BF4C2B07BB}"/>
+              </a:ext>
+            </a:extLst>
+          </p:cNvPr>
+          <p:cNvPicPr>
+            <a:picLocks noChangeAspect="1"/>
+          </p:cNvPicPr>
+          <p:nvPr/>
+        </p:nvPicPr>
+        <p:blipFill>
+          <a:blip r:embed="rId5"/>
+          <a:stretch>
+            <a:fillRect/>
+          </a:stretch>
+        </p:blipFill>
+        <p:spPr>
+          <a:xfrm>
+            <a:off x="6148542" y="1421697"/>
+            <a:ext cx="5625311" cy="4981003"/>
+          </a:xfrm>
+          <a:prstGeom prst="rect">
+            <a:avLst/>
+          </a:prstGeom>
+          <a:ln>
+            <a:solidFill>
+              <a:schemeClr val="bg1"/>
+            </a:solidFill>
+          </a:ln>
+        </p:spPr>
+      </p:pic>
+      <p:pic>
+        <p:nvPicPr>
+          <p:cNvPr id="12" name="Picture 11">
+            <a:extLst>
+              <a:ext uri="{FF2B5EF4-FFF2-40B4-BE49-F238E27FC236}">
+                <a16:creationId xmlns:a16="http://schemas.microsoft.com/office/drawing/2014/main" id="{3A4C90B6-4484-9DCC-8F17-839837DC4354}"/>
+              </a:ext>
+            </a:extLst>
+          </p:cNvPr>
+          <p:cNvPicPr>
+            <a:picLocks noChangeAspect="1"/>
+          </p:cNvPicPr>
+          <p:nvPr/>
+        </p:nvPicPr>
+        <p:blipFill>
+          <a:blip r:embed="rId6"/>
+          <a:stretch>
+            <a:fillRect/>
+          </a:stretch>
+        </p:blipFill>
+        <p:spPr>
+          <a:xfrm>
+            <a:off x="708913" y="1331523"/>
+            <a:ext cx="4878766" cy="5161352"/>
+          </a:xfrm>
+          <a:prstGeom prst="rect">
+            <a:avLst/>
+          </a:prstGeom>
+          <a:ln>
+            <a:solidFill>
+              <a:schemeClr val="bg1"/>
+            </a:solidFill>
+          </a:ln>
+        </p:spPr>
+      </p:pic>
+      <p:sp>
+        <p:nvSpPr>
+          <p:cNvPr id="13" name="Content Placeholder 2">
+            <a:extLst>
+              <a:ext uri="{FF2B5EF4-FFF2-40B4-BE49-F238E27FC236}">
+                <a16:creationId xmlns:a16="http://schemas.microsoft.com/office/drawing/2014/main" id="{4B52CA67-74DA-CE30-6357-BD156AF87FE4}"/>
+              </a:ext>
+            </a:extLst>
+          </p:cNvPr>
+          <p:cNvSpPr>
+            <a:spLocks noGrp="1"/>
+          </p:cNvSpPr>
+          <p:nvPr>
+            <p:ph idx="1"/>
+          </p:nvPr>
+        </p:nvSpPr>
+        <p:spPr>
+          <a:xfrm>
+            <a:off x="9350138" y="6492875"/>
+            <a:ext cx="3124200" cy="549275"/>
+          </a:xfrm>
+        </p:spPr>
+        <p:txBody>
+          <a:bodyPr>
+            <a:normAutofit/>
+          </a:bodyPr>
+          <a:lstStyle/>
+          <a:p>
+            <a:r>
+              <a:rPr lang="en-US" sz="1400" dirty="0">
+                <a:ln w="3175">
+                  <a:solidFill>
+                    <a:schemeClr val="tx1"/>
+                  </a:solidFill>
+                </a:ln>
+                <a:solidFill>
+                  <a:schemeClr val="bg1"/>
+                </a:solidFill>
+                <a:latin typeface="Cooper Black" panose="0208090404030B020404" pitchFamily="18" charset="77"/>
+              </a:rPr>
+              <a:t>Note: I followed a tutorial</a:t>
+            </a:r>
+          </a:p>
+        </p:txBody>
+      </p:sp>
+    </p:spTree>
+    <p:extLst>
+      <p:ext uri="{BB962C8B-B14F-4D97-AF65-F5344CB8AC3E}">
+        <p14:creationId xmlns:p14="http://schemas.microsoft.com/office/powerpoint/2010/main" val="4008242750"/>
       </p:ext>
     </p:extLst>
   </p:cSld>

</xml_diff>